<commit_message>
Update slide presentation with new content
</commit_message>
<xml_diff>
--- a/slide.pptx
+++ b/slide.pptx
@@ -296,6 +296,89 @@
           <a:bodyPr/>
           <a:lstStyle/>
           <a:p>
+            <a:r>
+              <a:rPr lang="vi-VN" sz="1200" b="0" i="0" kern="1200">
+                <a:solidFill>
+                  <a:schemeClr val="tx1"/>
+                </a:solidFill>
+                <a:effectLst/>
+                <a:latin typeface="+mn-lt"/>
+                <a:ea typeface="+mn-ea"/>
+                <a:cs typeface="+mn-cs"/>
+              </a:rPr>
+              <a:t>Chào thầy/cô, em xin trình bày đồ án cuối kỳ môn Học sâu. Đề tài của em là </a:t>
+            </a:r>
+            <a:r>
+              <a:rPr lang="vi-VN" sz="1200" b="1" i="0" kern="1200">
+                <a:solidFill>
+                  <a:schemeClr val="tx1"/>
+                </a:solidFill>
+                <a:effectLst/>
+                <a:latin typeface="+mn-lt"/>
+                <a:ea typeface="+mn-ea"/>
+                <a:cs typeface="+mn-cs"/>
+              </a:rPr>
+              <a:t>hệ thống hỏi đáp ảnh biển báo giao thông tiếng Việt</a:t>
+            </a:r>
+            <a:r>
+              <a:rPr lang="vi-VN" sz="1200" b="0" i="0" kern="1200">
+                <a:solidFill>
+                  <a:schemeClr val="tx1"/>
+                </a:solidFill>
+                <a:effectLst/>
+                <a:latin typeface="+mn-lt"/>
+                <a:ea typeface="+mn-ea"/>
+                <a:cs typeface="+mn-cs"/>
+              </a:rPr>
+              <a:t>. Hệ thống nhận vào một ảnh biển báo và một câu hỏi tiếng Việt, sau đó sinh ra câu trả lời tương ứng.</a:t>
+            </a:r>
+            <a:endParaRPr lang="en-US" sz="1200" b="0" i="0" kern="1200">
+              <a:solidFill>
+                <a:schemeClr val="tx1"/>
+              </a:solidFill>
+              <a:effectLst/>
+              <a:latin typeface="+mn-lt"/>
+              <a:ea typeface="+mn-ea"/>
+              <a:cs typeface="+mn-cs"/>
+            </a:endParaRPr>
+          </a:p>
+          <a:p>
+            <a:r>
+              <a:rPr lang="vi-VN" sz="1200" b="0" i="0" kern="1200">
+                <a:solidFill>
+                  <a:schemeClr val="tx1"/>
+                </a:solidFill>
+                <a:effectLst/>
+                <a:latin typeface="+mn-lt"/>
+                <a:ea typeface="+mn-ea"/>
+                <a:cs typeface="+mn-cs"/>
+              </a:rPr>
+              <a:t>Ngoài Bài 1 là VQA, em cũng mở rộng sang Bài 2 là </a:t>
+            </a:r>
+            <a:r>
+              <a:rPr lang="vi-VN" sz="1200" b="1" i="0" kern="1200">
+                <a:solidFill>
+                  <a:schemeClr val="tx1"/>
+                </a:solidFill>
+                <a:effectLst/>
+                <a:latin typeface="+mn-lt"/>
+                <a:ea typeface="+mn-ea"/>
+                <a:cs typeface="+mn-cs"/>
+              </a:rPr>
+              <a:t>Explainable VQA</a:t>
+            </a:r>
+            <a:r>
+              <a:rPr lang="vi-VN" sz="1200" b="0" i="0" kern="1200">
+                <a:solidFill>
+                  <a:schemeClr val="tx1"/>
+                </a:solidFill>
+                <a:effectLst/>
+                <a:latin typeface="+mn-lt"/>
+                <a:ea typeface="+mn-ea"/>
+                <a:cs typeface="+mn-cs"/>
+              </a:rPr>
+              <a:t>, tức là ngoài câu trả lời, hệ thống còn đưa ra giải thích, khuyến nghị hành động và độ tin cậy.</a:t>
+            </a:r>
             <a:endParaRPr lang="en-US" dirty="0"/>
           </a:p>
         </p:txBody>
@@ -380,6 +463,34 @@
           <a:bodyPr/>
           <a:lstStyle/>
           <a:p>
+            <a:r>
+              <a:rPr lang="vi-VN" sz="1200" b="0" i="0" kern="1200">
+                <a:solidFill>
+                  <a:schemeClr val="tx1"/>
+                </a:solidFill>
+                <a:effectLst/>
+                <a:latin typeface="+mn-lt"/>
+                <a:ea typeface="+mn-ea"/>
+                <a:cs typeface="+mn-cs"/>
+              </a:rPr>
+              <a:t>Metric chính em dùng là Exact Match và validation accuracy. Exact Match yêu cầu câu trả lời dự đoán phải khớp với ground truth sau chuẩn hóa, nên đây là metric khá nghiêm ngặt.</a:t>
+            </a:r>
+          </a:p>
+          <a:p>
+            <a:r>
+              <a:rPr lang="vi-VN" sz="1200" b="0" i="0" kern="1200">
+                <a:solidFill>
+                  <a:schemeClr val="tx1"/>
+                </a:solidFill>
+                <a:effectLst/>
+                <a:latin typeface="+mn-lt"/>
+                <a:ea typeface="+mn-ea"/>
+                <a:cs typeface="+mn-cs"/>
+              </a:rPr>
+              <a:t>Trong báo cáo, em cũng phân tích thêm các metric khác thường dùng cho VQA và sinh văn bản như soft VQA accuracy, BLEU, ROUGE-L, METEOR, BERTScore và LLM-as-a-judge. Những metric này giúp đánh giá tốt hơn trong trường hợp câu trả lời đúng ý nhưng khác cách diễn đạt.</a:t>
+            </a:r>
+          </a:p>
+          <a:p>
             <a:endParaRPr lang="en-US" dirty="0"/>
           </a:p>
         </p:txBody>
@@ -464,6 +575,34 @@
           <a:bodyPr/>
           <a:lstStyle/>
           <a:p>
+            <a:r>
+              <a:rPr lang="vi-VN" sz="1200" b="0" i="0" kern="1200">
+                <a:solidFill>
+                  <a:schemeClr val="tx1"/>
+                </a:solidFill>
+                <a:effectLst/>
+                <a:latin typeface="+mn-lt"/>
+                <a:ea typeface="+mn-ea"/>
+                <a:cs typeface="+mn-cs"/>
+              </a:rPr>
+              <a:t>Về demo, em có demo local bằng FastAPI và giao diện HTML. Người dùng có thể upload ảnh, nhập câu hỏi và chọn model.</a:t>
+            </a:r>
+          </a:p>
+          <a:p>
+            <a:r>
+              <a:rPr lang="vi-VN" sz="1200" b="0" i="0" kern="1200">
+                <a:solidFill>
+                  <a:schemeClr val="tx1"/>
+                </a:solidFill>
+                <a:effectLst/>
+                <a:latin typeface="+mn-lt"/>
+                <a:ea typeface="+mn-ea"/>
+                <a:cs typeface="+mn-cs"/>
+              </a:rPr>
+              <a:t>A1 và A2 chạy realtime bằng checkpoint PyTorch trên local. Với B1 và B2, do Qwen2-VL khá nặng, bản local có thể dùng prediction đã lưu. Ngoài ra, em có demo Gradio trên Colab để chạy B1/B2 realtime bằng GPU T4.</a:t>
+            </a:r>
+          </a:p>
+          <a:p>
             <a:endParaRPr lang="en-US" dirty="0"/>
           </a:p>
         </p:txBody>
@@ -548,6 +687,58 @@
           <a:bodyPr/>
           <a:lstStyle/>
           <a:p>
+            <a:r>
+              <a:rPr lang="en-US" sz="1200" b="0" i="0" kern="1200">
+                <a:solidFill>
+                  <a:schemeClr val="tx1"/>
+                </a:solidFill>
+                <a:effectLst/>
+                <a:latin typeface="+mn-lt"/>
+                <a:ea typeface="+mn-ea"/>
+                <a:cs typeface="+mn-cs"/>
+              </a:rPr>
+              <a:t>Với Bài 2, em mở rộng hệ thống VQA thành </a:t>
+            </a:r>
+            <a:r>
+              <a:rPr lang="en-US" sz="1200" b="1" i="0" kern="1200">
+                <a:solidFill>
+                  <a:schemeClr val="tx1"/>
+                </a:solidFill>
+                <a:effectLst/>
+                <a:latin typeface="+mn-lt"/>
+                <a:ea typeface="+mn-ea"/>
+                <a:cs typeface="+mn-cs"/>
+              </a:rPr>
+              <a:t>Explainable VQA</a:t>
+            </a:r>
+            <a:r>
+              <a:rPr lang="en-US" sz="1200" b="0" i="0" kern="1200">
+                <a:solidFill>
+                  <a:schemeClr val="tx1"/>
+                </a:solidFill>
+                <a:effectLst/>
+                <a:latin typeface="+mn-lt"/>
+                <a:ea typeface="+mn-ea"/>
+                <a:cs typeface="+mn-cs"/>
+              </a:rPr>
+              <a:t>. Thay vì chỉ trả lời câu hỏi, hệ thống sẽ sinh thêm nhóm biển suy luận, giải thích ngắn, khuyến nghị hành động và confidence heuristic.</a:t>
+            </a:r>
+          </a:p>
+          <a:p>
+            <a:r>
+              <a:rPr lang="en-US" sz="1200" b="0" i="0" kern="1200">
+                <a:solidFill>
+                  <a:schemeClr val="tx1"/>
+                </a:solidFill>
+                <a:effectLst/>
+                <a:latin typeface="+mn-lt"/>
+                <a:ea typeface="+mn-ea"/>
+                <a:cs typeface="+mn-cs"/>
+              </a:rPr>
+              <a:t>Ví dụ, nếu câu trả lời có dấu hiệu “cấm”, hệ thống sẽ khuyến nghị không thực hiện hành vi bị cấm. Nếu là biển cảnh báo nguy hiểm, hệ thống khuyến nghị giảm tốc độ và chú ý quan sát.</a:t>
+            </a:r>
+          </a:p>
+          <a:p>
             <a:endParaRPr lang="en-US" dirty="0"/>
           </a:p>
         </p:txBody>
@@ -632,6 +823,34 @@
           <a:bodyPr/>
           <a:lstStyle/>
           <a:p>
+            <a:r>
+              <a:rPr lang="vi-VN" sz="1200" b="0" i="0" kern="1200">
+                <a:solidFill>
+                  <a:schemeClr val="tx1"/>
+                </a:solidFill>
+                <a:effectLst/>
+                <a:latin typeface="+mn-lt"/>
+                <a:ea typeface="+mn-ea"/>
+                <a:cs typeface="+mn-cs"/>
+              </a:rPr>
+              <a:t>Hiện tại đồ án vẫn có một số hạn chế. Thứ nhất, dataset còn nhỏ so với bài toán VQA thực tế. Thứ hai, các câu hỏi về ý nghĩa biển báo khó hơn nhiều so với câu hỏi về màu sắc, hình dạng hay số lượng.</a:t>
+            </a:r>
+          </a:p>
+          <a:p>
+            <a:r>
+              <a:rPr lang="vi-VN" sz="1200" b="0" i="0" kern="1200">
+                <a:solidFill>
+                  <a:schemeClr val="tx1"/>
+                </a:solidFill>
+                <a:effectLst/>
+                <a:latin typeface="+mn-lt"/>
+                <a:ea typeface="+mn-ea"/>
+                <a:cs typeface="+mn-cs"/>
+              </a:rPr>
+              <a:t>Ngoài ra, Qwen2-VL cần GPU khá mạnh nên máy local GTX 1650 không phù hợp để chạy realtime ổn định. Cuối cùng, Exact Match là metric nghiêm ngặt, có thể đánh giá thấp những câu trả lời đúng ngữ nghĩa nhưng khác cách diễn đạt.</a:t>
+            </a:r>
+          </a:p>
+          <a:p>
             <a:endParaRPr lang="en-US" dirty="0"/>
           </a:p>
         </p:txBody>
@@ -716,6 +935,34 @@
           <a:bodyPr/>
           <a:lstStyle/>
           <a:p>
+            <a:r>
+              <a:rPr lang="vi-VN" sz="1200" b="0" i="0" kern="1200">
+                <a:solidFill>
+                  <a:schemeClr val="tx1"/>
+                </a:solidFill>
+                <a:effectLst/>
+                <a:latin typeface="+mn-lt"/>
+                <a:ea typeface="+mn-ea"/>
+                <a:cs typeface="+mn-cs"/>
+              </a:rPr>
+              <a:t>Trong tương lai, em có thể mở rộng dataset với nhiều loại biển báo và nhiều câu hỏi hơn. Em cũng muốn bổ sung các metric ngữ nghĩa như BERTScore, human evaluation hoặc LLM-as-a-judge.</a:t>
+            </a:r>
+          </a:p>
+          <a:p>
+            <a:r>
+              <a:rPr lang="vi-VN" sz="1200" b="0" i="0" kern="1200">
+                <a:solidFill>
+                  <a:schemeClr val="tx1"/>
+                </a:solidFill>
+                <a:effectLst/>
+                <a:latin typeface="+mn-lt"/>
+                <a:ea typeface="+mn-ea"/>
+                <a:cs typeface="+mn-cs"/>
+              </a:rPr>
+              <a:t>Ngoài ra, có thể fine-tune B2 lâu hơn, cải thiện chất lượng dữ liệu, hoặc nghiên cứu các hướng nâng cao như DPO/RLHF với preference data cho VQA.</a:t>
+            </a:r>
+          </a:p>
+          <a:p>
             <a:endParaRPr lang="en-US" dirty="0"/>
           </a:p>
         </p:txBody>
@@ -800,6 +1047,34 @@
           <a:bodyPr/>
           <a:lstStyle/>
           <a:p>
+            <a:r>
+              <a:rPr lang="vi-VN" sz="1200" b="0" i="0" kern="1200">
+                <a:solidFill>
+                  <a:schemeClr val="tx1"/>
+                </a:solidFill>
+                <a:effectLst/>
+                <a:latin typeface="+mn-lt"/>
+                <a:ea typeface="+mn-ea"/>
+                <a:cs typeface="+mn-cs"/>
+              </a:rPr>
+              <a:t>Tổng kết lại, đồ án đã xây dựng được hệ thống VQA tiếng Việt cho miền biển báo giao thông. Em đã triển khai đủ bốn cấu hình theo yêu cầu: A1, A2, B1 và B2. Kết quả cho thấy Transformer decoder tốt hơn LSTM decoder, và B2 sau fine-tune LoRA cải thiện rõ so với B1 zero-shot.</a:t>
+            </a:r>
+          </a:p>
+          <a:p>
+            <a:r>
+              <a:rPr lang="vi-VN" sz="1200" b="0" i="0" kern="1200">
+                <a:solidFill>
+                  <a:schemeClr val="tx1"/>
+                </a:solidFill>
+                <a:effectLst/>
+                <a:latin typeface="+mn-lt"/>
+                <a:ea typeface="+mn-ea"/>
+                <a:cs typeface="+mn-cs"/>
+              </a:rPr>
+              <a:t>Ngoài ra, em đã có demo local, demo Colab realtime cho Qwen, và mở rộng Bài 2 thành Explainable VQA.</a:t>
+            </a:r>
+          </a:p>
+          <a:p>
             <a:endParaRPr lang="en-US" dirty="0"/>
           </a:p>
         </p:txBody>
@@ -968,6 +1243,34 @@
           <a:bodyPr/>
           <a:lstStyle/>
           <a:p>
+            <a:r>
+              <a:rPr lang="vi-VN" sz="1200" b="0" i="0" kern="1200">
+                <a:solidFill>
+                  <a:schemeClr val="tx1"/>
+                </a:solidFill>
+                <a:effectLst/>
+                <a:latin typeface="+mn-lt"/>
+                <a:ea typeface="+mn-ea"/>
+                <a:cs typeface="+mn-cs"/>
+              </a:rPr>
+              <a:t>Bài toán em giải quyết là Visual Question Answering trên miền biển báo giao thông. Đầu vào gồm ảnh và câu hỏi, ví dụ “Biển báo này có ý nghĩa gì?”, “Màu nền của biển báo là gì?”, hoặc “Có bao nhiêu mũi tên?”.</a:t>
+            </a:r>
+          </a:p>
+          <a:p>
+            <a:r>
+              <a:rPr lang="vi-VN" sz="1200" b="0" i="0" kern="1200">
+                <a:solidFill>
+                  <a:schemeClr val="tx1"/>
+                </a:solidFill>
+                <a:effectLst/>
+                <a:latin typeface="+mn-lt"/>
+                <a:ea typeface="+mn-ea"/>
+                <a:cs typeface="+mn-cs"/>
+              </a:rPr>
+              <a:t>Đầu ra là câu trả lời ngắn bằng tiếng Việt. Với Bài 2, em mở rộng thêm phần giải thích và khuyến nghị, để hệ thống không chỉ trả lời mà còn hỗ trợ người dùng hiểu nên làm gì khi gặp biển báo.</a:t>
+            </a:r>
+          </a:p>
+          <a:p>
             <a:endParaRPr lang="en-US" dirty="0"/>
           </a:p>
         </p:txBody>
@@ -1052,6 +1355,34 @@
           <a:bodyPr/>
           <a:lstStyle/>
           <a:p>
+            <a:r>
+              <a:rPr lang="vi-VN" sz="1200" b="0" i="0" kern="1200">
+                <a:solidFill>
+                  <a:schemeClr val="tx1"/>
+                </a:solidFill>
+                <a:effectLst/>
+                <a:latin typeface="+mn-lt"/>
+                <a:ea typeface="+mn-ea"/>
+                <a:cs typeface="+mn-cs"/>
+              </a:rPr>
+              <a:t>Em chọn biển báo giao thông vì đây là miền chuyên biệt và có ý nghĩa thực tế. Ảnh biển báo có nhiều đặc trưng trực quan như màu sắc, hình dạng, biểu tượng và chữ viết. Những đặc trưng này rất phù hợp cho bài toán kết hợp thị giác và ngôn ngữ.</a:t>
+            </a:r>
+          </a:p>
+          <a:p>
+            <a:r>
+              <a:rPr lang="vi-VN" sz="1200" b="0" i="0" kern="1200">
+                <a:solidFill>
+                  <a:schemeClr val="tx1"/>
+                </a:solidFill>
+                <a:effectLst/>
+                <a:latin typeface="+mn-lt"/>
+                <a:ea typeface="+mn-ea"/>
+                <a:cs typeface="+mn-cs"/>
+              </a:rPr>
+              <a:t>Ngoài ra, câu hỏi trong miền này cũng khá đa dạng, từ yes/no, nhận dạng loại biển, hỏi màu sắc, hình dạng, số lượng, đến hỏi hành động người lái xe nên thực hiện.</a:t>
+            </a:r>
+          </a:p>
+          <a:p>
             <a:endParaRPr lang="en-US" dirty="0"/>
           </a:p>
         </p:txBody>
@@ -1136,6 +1467,82 @@
           <a:bodyPr/>
           <a:lstStyle/>
           <a:p>
+            <a:r>
+              <a:rPr lang="vi-VN" sz="1200" b="0" i="0" kern="1200">
+                <a:solidFill>
+                  <a:schemeClr val="tx1"/>
+                </a:solidFill>
+                <a:effectLst/>
+                <a:latin typeface="+mn-lt"/>
+                <a:ea typeface="+mn-ea"/>
+                <a:cs typeface="+mn-cs"/>
+              </a:rPr>
+              <a:t>Bộ dữ liệu của em gồm </a:t>
+            </a:r>
+            <a:r>
+              <a:rPr lang="vi-VN" sz="1200" b="1" i="0" kern="1200">
+                <a:solidFill>
+                  <a:schemeClr val="tx1"/>
+                </a:solidFill>
+                <a:effectLst/>
+                <a:latin typeface="+mn-lt"/>
+                <a:ea typeface="+mn-ea"/>
+                <a:cs typeface="+mn-cs"/>
+              </a:rPr>
+              <a:t>258 ảnh</a:t>
+            </a:r>
+            <a:r>
+              <a:rPr lang="vi-VN" sz="1200" b="0" i="0" kern="1200">
+                <a:solidFill>
+                  <a:schemeClr val="tx1"/>
+                </a:solidFill>
+                <a:effectLst/>
+                <a:latin typeface="+mn-lt"/>
+                <a:ea typeface="+mn-ea"/>
+                <a:cs typeface="+mn-cs"/>
+              </a:rPr>
+              <a:t> và </a:t>
+            </a:r>
+            <a:r>
+              <a:rPr lang="vi-VN" sz="1200" b="1" i="0" kern="1200">
+                <a:solidFill>
+                  <a:schemeClr val="tx1"/>
+                </a:solidFill>
+                <a:effectLst/>
+                <a:latin typeface="+mn-lt"/>
+                <a:ea typeface="+mn-ea"/>
+                <a:cs typeface="+mn-cs"/>
+              </a:rPr>
+              <a:t>2580 cặp hỏi đáp</a:t>
+            </a:r>
+            <a:r>
+              <a:rPr lang="vi-VN" sz="1200" b="0" i="0" kern="1200">
+                <a:solidFill>
+                  <a:schemeClr val="tx1"/>
+                </a:solidFill>
+                <a:effectLst/>
+                <a:latin typeface="+mn-lt"/>
+                <a:ea typeface="+mn-ea"/>
+                <a:cs typeface="+mn-cs"/>
+              </a:rPr>
+              <a:t>. Mỗi ảnh có 10 câu hỏi - câu trả lời. Dữ liệu được chia thành train, validation và test theo tỉ lệ gần 80/10/10.</a:t>
+            </a:r>
+          </a:p>
+          <a:p>
+            <a:r>
+              <a:rPr lang="vi-VN" sz="1200" b="0" i="0" kern="1200">
+                <a:solidFill>
+                  <a:schemeClr val="tx1"/>
+                </a:solidFill>
+                <a:effectLst/>
+                <a:latin typeface="+mn-lt"/>
+                <a:ea typeface="+mn-ea"/>
+                <a:cs typeface="+mn-cs"/>
+              </a:rPr>
+              <a:t>Cụ thể, train có 206 ảnh với 2060 QA, validation có 25 ảnh với 250 QA, và test có 27 ảnh với 270 QA. Các ảnh giữa train, validation và test không bị trùng nhau. Câu trả lời được giữ ngắn, đa số không quá 10 từ.</a:t>
+            </a:r>
+          </a:p>
+          <a:p>
             <a:endParaRPr lang="en-US" dirty="0"/>
           </a:p>
         </p:txBody>
@@ -1220,6 +1627,34 @@
           <a:bodyPr/>
           <a:lstStyle/>
           <a:p>
+            <a:r>
+              <a:rPr lang="vi-VN" sz="1200" b="0" i="0" kern="1200">
+                <a:solidFill>
+                  <a:schemeClr val="tx1"/>
+                </a:solidFill>
+                <a:effectLst/>
+                <a:latin typeface="+mn-lt"/>
+                <a:ea typeface="+mn-ea"/>
+                <a:cs typeface="+mn-cs"/>
+              </a:rPr>
+              <a:t>Với ảnh đầu vào, em dùng pipeline: SquarePad, sau đó resize về 224x224, chuyển tensor và normalize.</a:t>
+            </a:r>
+          </a:p>
+          <a:p>
+            <a:r>
+              <a:rPr lang="vi-VN" sz="1200" b="0" i="0" kern="1200">
+                <a:solidFill>
+                  <a:schemeClr val="tx1"/>
+                </a:solidFill>
+                <a:effectLst/>
+                <a:latin typeface="+mn-lt"/>
+                <a:ea typeface="+mn-ea"/>
+                <a:cs typeface="+mn-cs"/>
+              </a:rPr>
+              <a:t>Lý do dùng SquarePad là vì nếu resize trực tiếp, hình dạng biển báo có thể bị méo, ví dụ biển tròn thành elip hoặc tam giác bị biến dạng. Padding ảnh thành hình vuông trước giúp giữ đúng tỷ lệ hình dạng biển báo.</a:t>
+            </a:r>
+          </a:p>
+          <a:p>
             <a:endParaRPr lang="en-US" dirty="0"/>
           </a:p>
         </p:txBody>
@@ -1304,6 +1739,82 @@
           <a:bodyPr/>
           <a:lstStyle/>
           <a:p>
+            <a:r>
+              <a:rPr lang="vi-VN" sz="1200" b="0" i="0" kern="1200">
+                <a:solidFill>
+                  <a:schemeClr val="tx1"/>
+                </a:solidFill>
+                <a:effectLst/>
+                <a:latin typeface="+mn-lt"/>
+                <a:ea typeface="+mn-ea"/>
+                <a:cs typeface="+mn-cs"/>
+              </a:rPr>
+              <a:t>Ở Hướng A, em xây dựng mô hình theo kiến trúc rời. Image encoder dùng CNN pretrained để trích xuất đặc trưng ảnh. Text encoder dùng LSTM/BiLSTM để mã hóa câu hỏi. Sau đó đặc trưng ảnh và câu hỏi được fusion để đưa vào answer decoder.</a:t>
+            </a:r>
+          </a:p>
+          <a:p>
+            <a:r>
+              <a:rPr lang="vi-VN" sz="1200" b="0" i="0" kern="1200">
+                <a:solidFill>
+                  <a:schemeClr val="tx1"/>
+                </a:solidFill>
+                <a:effectLst/>
+                <a:latin typeface="+mn-lt"/>
+                <a:ea typeface="+mn-ea"/>
+                <a:cs typeface="+mn-cs"/>
+              </a:rPr>
+              <a:t>Theo yêu cầu đề bài, em triển khai hai decoder để so sánh. A1 dùng </a:t>
+            </a:r>
+            <a:r>
+              <a:rPr lang="vi-VN" sz="1200" b="1" i="0" kern="1200">
+                <a:solidFill>
+                  <a:schemeClr val="tx1"/>
+                </a:solidFill>
+                <a:effectLst/>
+                <a:latin typeface="+mn-lt"/>
+                <a:ea typeface="+mn-ea"/>
+                <a:cs typeface="+mn-cs"/>
+              </a:rPr>
+              <a:t>LSTM decoder</a:t>
+            </a:r>
+            <a:r>
+              <a:rPr lang="vi-VN" sz="1200" b="0" i="0" kern="1200">
+                <a:solidFill>
+                  <a:schemeClr val="tx1"/>
+                </a:solidFill>
+                <a:effectLst/>
+                <a:latin typeface="+mn-lt"/>
+                <a:ea typeface="+mn-ea"/>
+                <a:cs typeface="+mn-cs"/>
+              </a:rPr>
+              <a:t>, còn A2 dùng </a:t>
+            </a:r>
+            <a:r>
+              <a:rPr lang="vi-VN" sz="1200" b="1" i="0" kern="1200">
+                <a:solidFill>
+                  <a:schemeClr val="tx1"/>
+                </a:solidFill>
+                <a:effectLst/>
+                <a:latin typeface="+mn-lt"/>
+                <a:ea typeface="+mn-ea"/>
+                <a:cs typeface="+mn-cs"/>
+              </a:rPr>
+              <a:t>Transformer decoder</a:t>
+            </a:r>
+            <a:r>
+              <a:rPr lang="vi-VN" sz="1200" b="0" i="0" kern="1200">
+                <a:solidFill>
+                  <a:schemeClr val="tx1"/>
+                </a:solidFill>
+                <a:effectLst/>
+                <a:latin typeface="+mn-lt"/>
+                <a:ea typeface="+mn-ea"/>
+                <a:cs typeface="+mn-cs"/>
+              </a:rPr>
+              <a:t>. Hai mô hình giữ cùng image encoder và text encoder, chỉ khác phần decoder.</a:t>
+            </a:r>
+          </a:p>
+          <a:p>
             <a:endParaRPr lang="en-US" dirty="0"/>
           </a:p>
         </p:txBody>
@@ -1388,6 +1899,72 @@
           <a:bodyPr/>
           <a:lstStyle/>
           <a:p>
+            <a:r>
+              <a:rPr lang="vi-VN" sz="1200" b="0" i="0" kern="1200">
+                <a:solidFill>
+                  <a:schemeClr val="tx1"/>
+                </a:solidFill>
+                <a:effectLst/>
+                <a:latin typeface="+mn-lt"/>
+                <a:ea typeface="+mn-ea"/>
+                <a:cs typeface="+mn-cs"/>
+              </a:rPr>
+              <a:t>Ở Hướng B, em sử dụng mô hình pretrained đa phương thức </a:t>
+            </a:r>
+            <a:r>
+              <a:rPr lang="vi-VN" sz="1200" b="1" i="0" kern="1200">
+                <a:solidFill>
+                  <a:schemeClr val="tx1"/>
+                </a:solidFill>
+                <a:effectLst/>
+                <a:latin typeface="+mn-lt"/>
+                <a:ea typeface="+mn-ea"/>
+                <a:cs typeface="+mn-cs"/>
+              </a:rPr>
+              <a:t>Qwen2-VL-2B-Instruct</a:t>
+            </a:r>
+            <a:r>
+              <a:rPr lang="vi-VN" sz="1200" b="0" i="0" kern="1200">
+                <a:solidFill>
+                  <a:schemeClr val="tx1"/>
+                </a:solidFill>
+                <a:effectLst/>
+                <a:latin typeface="+mn-lt"/>
+                <a:ea typeface="+mn-ea"/>
+                <a:cs typeface="+mn-cs"/>
+              </a:rPr>
+              <a:t>.</a:t>
+            </a:r>
+          </a:p>
+          <a:p>
+            <a:r>
+              <a:rPr lang="vi-VN" sz="1200" b="0" i="0" kern="1200">
+                <a:solidFill>
+                  <a:schemeClr val="tx1"/>
+                </a:solidFill>
+                <a:effectLst/>
+                <a:latin typeface="+mn-lt"/>
+                <a:ea typeface="+mn-ea"/>
+                <a:cs typeface="+mn-cs"/>
+              </a:rPr>
+              <a:t>B1 là cấu hình zero-shot, tức là dùng model gốc để suy luận trực tiếp, không fine-tune. B2 là cấu hình fine-tuned bằng LoRA. Em dùng LoRA vì full fine-tune Qwen2-VL rất nặng, còn LoRA chỉ huấn luyện một phần nhỏ tham số nên phù hợp với Colab T4.</a:t>
+            </a:r>
+          </a:p>
+          <a:p>
+            <a:r>
+              <a:rPr lang="vi-VN" sz="1200" b="0" i="0" kern="1200">
+                <a:solidFill>
+                  <a:schemeClr val="tx1"/>
+                </a:solidFill>
+                <a:effectLst/>
+                <a:latin typeface="+mn-lt"/>
+                <a:ea typeface="+mn-ea"/>
+                <a:cs typeface="+mn-cs"/>
+              </a:rPr>
+              <a:t>Về tiếng Việt, em dùng trực tiếp prompt và câu hỏi tiếng Việt, không dịch sang tiếng Anh.</a:t>
+            </a:r>
+          </a:p>
+          <a:p>
             <a:endParaRPr lang="en-US" dirty="0"/>
           </a:p>
         </p:txBody>
@@ -1472,6 +2049,34 @@
           <a:bodyPr/>
           <a:lstStyle/>
           <a:p>
+            <a:r>
+              <a:rPr lang="vi-VN" sz="1200" b="0" i="0" kern="1200">
+                <a:solidFill>
+                  <a:schemeClr val="tx1"/>
+                </a:solidFill>
+                <a:effectLst/>
+                <a:latin typeface="+mn-lt"/>
+                <a:ea typeface="+mn-ea"/>
+                <a:cs typeface="+mn-cs"/>
+              </a:rPr>
+              <a:t>Với A1 và A2, em train trên train.json, theo dõi loss và accuracy trên validation, đồng thời lưu cả best checkpoint và latest checkpoint để có thể resume nếu bị ngắt giữa chừng.</a:t>
+            </a:r>
+          </a:p>
+          <a:p>
+            <a:r>
+              <a:rPr lang="vi-VN" sz="1200" b="0" i="0" kern="1200">
+                <a:solidFill>
+                  <a:schemeClr val="tx1"/>
+                </a:solidFill>
+                <a:effectLst/>
+                <a:latin typeface="+mn-lt"/>
+                <a:ea typeface="+mn-ea"/>
+                <a:cs typeface="+mn-cs"/>
+              </a:rPr>
+              <a:t>Với B2, em fine-tune Qwen2-VL bằng LoRA trên Colab T4. Adapter LoRA khá nhẹ, còn base model được tải từ Hugging Face và có thể cache vào Google Drive để tránh tải lại nhiều lần.</a:t>
+            </a:r>
+          </a:p>
+          <a:p>
             <a:endParaRPr lang="en-US" dirty="0"/>
           </a:p>
         </p:txBody>
@@ -1555,6 +2160,130 @@
         <p:txBody>
           <a:bodyPr/>
           <a:lstStyle/>
+          <a:p>
+            <a:r>
+              <a:rPr lang="vi-VN" sz="1200" b="0" i="0" kern="1200">
+                <a:solidFill>
+                  <a:schemeClr val="tx1"/>
+                </a:solidFill>
+                <a:effectLst/>
+                <a:latin typeface="+mn-lt"/>
+                <a:ea typeface="+mn-ea"/>
+                <a:cs typeface="+mn-cs"/>
+              </a:rPr>
+              <a:t>Đây là bảng kết quả chính. A1 đạt validation accuracy khoảng </a:t>
+            </a:r>
+            <a:r>
+              <a:rPr lang="vi-VN" sz="1200" b="1" i="0" kern="1200">
+                <a:solidFill>
+                  <a:schemeClr val="tx1"/>
+                </a:solidFill>
+                <a:effectLst/>
+                <a:latin typeface="+mn-lt"/>
+                <a:ea typeface="+mn-ea"/>
+                <a:cs typeface="+mn-cs"/>
+              </a:rPr>
+              <a:t>66.78%</a:t>
+            </a:r>
+            <a:r>
+              <a:rPr lang="vi-VN" sz="1200" b="0" i="0" kern="1200">
+                <a:solidFill>
+                  <a:schemeClr val="tx1"/>
+                </a:solidFill>
+                <a:effectLst/>
+                <a:latin typeface="+mn-lt"/>
+                <a:ea typeface="+mn-ea"/>
+                <a:cs typeface="+mn-cs"/>
+              </a:rPr>
+              <a:t>, còn A2 đạt khoảng </a:t>
+            </a:r>
+            <a:r>
+              <a:rPr lang="vi-VN" sz="1200" b="1" i="0" kern="1200">
+                <a:solidFill>
+                  <a:schemeClr val="tx1"/>
+                </a:solidFill>
+                <a:effectLst/>
+                <a:latin typeface="+mn-lt"/>
+                <a:ea typeface="+mn-ea"/>
+                <a:cs typeface="+mn-cs"/>
+              </a:rPr>
+              <a:t>74.97%</a:t>
+            </a:r>
+            <a:r>
+              <a:rPr lang="vi-VN" sz="1200" b="0" i="0" kern="1200">
+                <a:solidFill>
+                  <a:schemeClr val="tx1"/>
+                </a:solidFill>
+                <a:effectLst/>
+                <a:latin typeface="+mn-lt"/>
+                <a:ea typeface="+mn-ea"/>
+                <a:cs typeface="+mn-cs"/>
+              </a:rPr>
+              <a:t>. Điều này cho thấy Transformer decoder hoạt động tốt hơn LSTM decoder trong thiết lập của em.</a:t>
+            </a:r>
+          </a:p>
+          <a:p>
+            <a:r>
+              <a:rPr lang="vi-VN" sz="1200" b="0" i="0" kern="1200">
+                <a:solidFill>
+                  <a:schemeClr val="tx1"/>
+                </a:solidFill>
+                <a:effectLst/>
+                <a:latin typeface="+mn-lt"/>
+                <a:ea typeface="+mn-ea"/>
+                <a:cs typeface="+mn-cs"/>
+              </a:rPr>
+              <a:t>Với Hướng B, B1 zero-shot chỉ đạt exact match khoảng </a:t>
+            </a:r>
+            <a:r>
+              <a:rPr lang="vi-VN" sz="1200" b="1" i="0" kern="1200">
+                <a:solidFill>
+                  <a:schemeClr val="tx1"/>
+                </a:solidFill>
+                <a:effectLst/>
+                <a:latin typeface="+mn-lt"/>
+                <a:ea typeface="+mn-ea"/>
+                <a:cs typeface="+mn-cs"/>
+              </a:rPr>
+              <a:t>2.96%</a:t>
+            </a:r>
+            <a:r>
+              <a:rPr lang="vi-VN" sz="1200" b="0" i="0" kern="1200">
+                <a:solidFill>
+                  <a:schemeClr val="tx1"/>
+                </a:solidFill>
+                <a:effectLst/>
+                <a:latin typeface="+mn-lt"/>
+                <a:ea typeface="+mn-ea"/>
+                <a:cs typeface="+mn-cs"/>
+              </a:rPr>
+              <a:t>, vì model chưa được điều chỉnh theo miền biển báo Việt Nam. Sau khi fine-tune bằng LoRA, B2 đạt exact match khoảng </a:t>
+            </a:r>
+            <a:r>
+              <a:rPr lang="vi-VN" sz="1200" b="1" i="0" kern="1200">
+                <a:solidFill>
+                  <a:schemeClr val="tx1"/>
+                </a:solidFill>
+                <a:effectLst/>
+                <a:latin typeface="+mn-lt"/>
+                <a:ea typeface="+mn-ea"/>
+                <a:cs typeface="+mn-cs"/>
+              </a:rPr>
+              <a:t>43.33%</a:t>
+            </a:r>
+            <a:r>
+              <a:rPr lang="vi-VN" sz="1200" b="0" i="0" kern="1200">
+                <a:solidFill>
+                  <a:schemeClr val="tx1"/>
+                </a:solidFill>
+                <a:effectLst/>
+                <a:latin typeface="+mn-lt"/>
+                <a:ea typeface="+mn-ea"/>
+                <a:cs typeface="+mn-cs"/>
+              </a:rPr>
+              <a:t> trên 270 mẫu test. Điều này cho thấy fine-tuning giúp model thích nghi tốt hơn với domain.</a:t>
+            </a:r>
+          </a:p>
           <a:p>
             <a:endParaRPr lang="en-US" dirty="0"/>
           </a:p>
@@ -15455,7 +16184,7 @@
         <p:spPr>
           <a:xfrm>
             <a:off x="274320" y="960120"/>
-            <a:ext cx="4160520" cy="1417320"/>
+            <a:ext cx="1850813" cy="1417320"/>
           </a:xfrm>
           <a:prstGeom prst="rect">
             <a:avLst/>
@@ -15494,7 +16223,7 @@
         <p:spPr>
           <a:xfrm>
             <a:off x="274320" y="960120"/>
-            <a:ext cx="658368" cy="1417320"/>
+            <a:ext cx="419947" cy="1417320"/>
           </a:xfrm>
           <a:prstGeom prst="rect">
             <a:avLst/>
@@ -15525,7 +16254,7 @@
         </p:nvSpPr>
         <p:spPr>
           <a:xfrm>
-            <a:off x="274320" y="960120"/>
+            <a:off x="130387" y="960120"/>
             <a:ext cx="658368" cy="1417320"/>
           </a:xfrm>
           <a:prstGeom prst="rect">
@@ -15564,8 +16293,8 @@
         </p:nvSpPr>
         <p:spPr>
           <a:xfrm>
-            <a:off x="1024128" y="1069848"/>
-            <a:ext cx="3246120" cy="365760"/>
+            <a:off x="785707" y="1113367"/>
+            <a:ext cx="1339426" cy="365760"/>
           </a:xfrm>
           <a:prstGeom prst="rect">
             <a:avLst/>
@@ -15603,8 +16332,8 @@
         </p:nvSpPr>
         <p:spPr>
           <a:xfrm>
-            <a:off x="1024128" y="1435608"/>
-            <a:ext cx="3246120" cy="256032"/>
+            <a:off x="785707" y="1479127"/>
+            <a:ext cx="1339426" cy="256032"/>
           </a:xfrm>
           <a:prstGeom prst="rect">
             <a:avLst/>
@@ -15642,8 +16371,8 @@
         </p:nvSpPr>
         <p:spPr>
           <a:xfrm>
-            <a:off x="1024128" y="1645920"/>
-            <a:ext cx="3246120" cy="548640"/>
+            <a:off x="785707" y="1689439"/>
+            <a:ext cx="1339426" cy="548640"/>
           </a:xfrm>
           <a:prstGeom prst="rect">
             <a:avLst/>
@@ -15681,8 +16410,8 @@
         </p:nvSpPr>
         <p:spPr>
           <a:xfrm>
-            <a:off x="4709160" y="960120"/>
-            <a:ext cx="4160520" cy="1417320"/>
+            <a:off x="2216573" y="960120"/>
+            <a:ext cx="2271340" cy="1417320"/>
           </a:xfrm>
           <a:prstGeom prst="rect">
             <a:avLst/>
@@ -15720,8 +16449,8 @@
         </p:nvSpPr>
         <p:spPr>
           <a:xfrm>
-            <a:off x="4709160" y="960120"/>
-            <a:ext cx="658368" cy="1417320"/>
+            <a:off x="2216573" y="960120"/>
+            <a:ext cx="419947" cy="1417320"/>
           </a:xfrm>
           <a:prstGeom prst="rect">
             <a:avLst/>
@@ -15752,7 +16481,7 @@
         </p:nvSpPr>
         <p:spPr>
           <a:xfrm>
-            <a:off x="4709160" y="960120"/>
+            <a:off x="2116534" y="950976"/>
             <a:ext cx="658368" cy="1417320"/>
           </a:xfrm>
           <a:prstGeom prst="rect">
@@ -15791,8 +16520,8 @@
         </p:nvSpPr>
         <p:spPr>
           <a:xfrm>
-            <a:off x="5458968" y="1069848"/>
-            <a:ext cx="3246120" cy="365760"/>
+            <a:off x="2774902" y="1069848"/>
+            <a:ext cx="1518278" cy="365760"/>
           </a:xfrm>
           <a:prstGeom prst="rect">
             <a:avLst/>
@@ -15830,8 +16559,8 @@
         </p:nvSpPr>
         <p:spPr>
           <a:xfrm>
-            <a:off x="5458968" y="1435608"/>
-            <a:ext cx="3246120" cy="256032"/>
+            <a:off x="2774902" y="1435608"/>
+            <a:ext cx="1289678" cy="256032"/>
           </a:xfrm>
           <a:prstGeom prst="rect">
             <a:avLst/>
@@ -15869,8 +16598,8 @@
         </p:nvSpPr>
         <p:spPr>
           <a:xfrm>
-            <a:off x="5458968" y="1645920"/>
-            <a:ext cx="3246120" cy="548640"/>
+            <a:off x="2774902" y="1645920"/>
+            <a:ext cx="1442078" cy="548640"/>
           </a:xfrm>
           <a:prstGeom prst="rect">
             <a:avLst/>
@@ -15909,7 +16638,7 @@
         <p:spPr>
           <a:xfrm>
             <a:off x="274320" y="2587752"/>
-            <a:ext cx="4160520" cy="1417320"/>
+            <a:ext cx="1850813" cy="1417320"/>
           </a:xfrm>
           <a:prstGeom prst="rect">
             <a:avLst/>
@@ -15948,7 +16677,7 @@
         <p:spPr>
           <a:xfrm>
             <a:off x="274320" y="2587752"/>
-            <a:ext cx="658368" cy="1417320"/>
+            <a:ext cx="419947" cy="1417320"/>
           </a:xfrm>
           <a:prstGeom prst="rect">
             <a:avLst/>
@@ -15979,7 +16708,7 @@
         </p:nvSpPr>
         <p:spPr>
           <a:xfrm>
-            <a:off x="274320" y="2587752"/>
+            <a:off x="130387" y="2587752"/>
             <a:ext cx="658368" cy="1417320"/>
           </a:xfrm>
           <a:prstGeom prst="rect">
@@ -16018,8 +16747,8 @@
         </p:nvSpPr>
         <p:spPr>
           <a:xfrm>
-            <a:off x="1024128" y="2697480"/>
-            <a:ext cx="3246120" cy="365760"/>
+            <a:off x="785707" y="2740999"/>
+            <a:ext cx="1339426" cy="365760"/>
           </a:xfrm>
           <a:prstGeom prst="rect">
             <a:avLst/>
@@ -16057,8 +16786,8 @@
         </p:nvSpPr>
         <p:spPr>
           <a:xfrm>
-            <a:off x="1024128" y="3063240"/>
-            <a:ext cx="3246120" cy="256032"/>
+            <a:off x="785707" y="3106759"/>
+            <a:ext cx="1339426" cy="256032"/>
           </a:xfrm>
           <a:prstGeom prst="rect">
             <a:avLst/>
@@ -16096,8 +16825,8 @@
         </p:nvSpPr>
         <p:spPr>
           <a:xfrm>
-            <a:off x="1024128" y="3273552"/>
-            <a:ext cx="3246120" cy="548640"/>
+            <a:off x="785707" y="3317071"/>
+            <a:ext cx="1339426" cy="548640"/>
           </a:xfrm>
           <a:prstGeom prst="rect">
             <a:avLst/>
@@ -16135,8 +16864,8 @@
         </p:nvSpPr>
         <p:spPr>
           <a:xfrm>
-            <a:off x="4709160" y="2587752"/>
-            <a:ext cx="4160520" cy="1417320"/>
+            <a:off x="2216573" y="2587752"/>
+            <a:ext cx="2271340" cy="1417320"/>
           </a:xfrm>
           <a:prstGeom prst="rect">
             <a:avLst/>
@@ -16174,8 +16903,8 @@
         </p:nvSpPr>
         <p:spPr>
           <a:xfrm>
-            <a:off x="4709160" y="2587752"/>
-            <a:ext cx="658368" cy="1417320"/>
+            <a:off x="2216573" y="2587752"/>
+            <a:ext cx="419947" cy="1417320"/>
           </a:xfrm>
           <a:prstGeom prst="rect">
             <a:avLst/>
@@ -16206,7 +16935,7 @@
         </p:nvSpPr>
         <p:spPr>
           <a:xfrm>
-            <a:off x="4709160" y="2587752"/>
+            <a:off x="2116534" y="2578608"/>
             <a:ext cx="658368" cy="1417320"/>
           </a:xfrm>
           <a:prstGeom prst="rect">
@@ -16245,8 +16974,8 @@
         </p:nvSpPr>
         <p:spPr>
           <a:xfrm>
-            <a:off x="5458968" y="2697480"/>
-            <a:ext cx="3246120" cy="365760"/>
+            <a:off x="2774902" y="2697480"/>
+            <a:ext cx="1518278" cy="365760"/>
           </a:xfrm>
           <a:prstGeom prst="rect">
             <a:avLst/>
@@ -16284,8 +17013,8 @@
         </p:nvSpPr>
         <p:spPr>
           <a:xfrm>
-            <a:off x="5458968" y="3063240"/>
-            <a:ext cx="3246120" cy="256032"/>
+            <a:off x="2774902" y="3063240"/>
+            <a:ext cx="1289678" cy="256032"/>
           </a:xfrm>
           <a:prstGeom prst="rect">
             <a:avLst/>
@@ -16323,8 +17052,8 @@
         </p:nvSpPr>
         <p:spPr>
           <a:xfrm>
-            <a:off x="5458968" y="3273552"/>
-            <a:ext cx="3246120" cy="548640"/>
+            <a:off x="2774902" y="3273552"/>
+            <a:ext cx="1518278" cy="548640"/>
           </a:xfrm>
           <a:prstGeom prst="rect">
             <a:avLst/>
@@ -16432,6 +17161,36 @@
           </a:p>
         </p:txBody>
       </p:sp>
+      <p:pic>
+        <p:nvPicPr>
+          <p:cNvPr id="32" name="Picture 31">
+            <a:extLst>
+              <a:ext uri="{FF2B5EF4-FFF2-40B4-BE49-F238E27FC236}">
+                <a16:creationId xmlns:a16="http://schemas.microsoft.com/office/drawing/2014/main" id="{AB481BCD-9098-2EE6-0BEE-8B1E3FA9F1CC}"/>
+              </a:ext>
+            </a:extLst>
+          </p:cNvPr>
+          <p:cNvPicPr>
+            <a:picLocks noChangeAspect="1"/>
+          </p:cNvPicPr>
+          <p:nvPr/>
+        </p:nvPicPr>
+        <p:blipFill>
+          <a:blip r:embed="rId3"/>
+          <a:stretch>
+            <a:fillRect/>
+          </a:stretch>
+        </p:blipFill>
+        <p:spPr>
+          <a:xfrm>
+            <a:off x="4579353" y="960119"/>
+            <a:ext cx="4198931" cy="2679462"/>
+          </a:xfrm>
+          <a:prstGeom prst="rect">
+            <a:avLst/>
+          </a:prstGeom>
+        </p:spPr>
+      </p:pic>
     </p:spTree>
   </p:cSld>
   <p:clrMapOvr>

</xml_diff>